<commit_message>
Open House post v3: remove micrographs and the man with the hose
Co-Authored-By: Claude Opus 5.5 <noreply@anthropic.com>
Claude-Session: https://claude.ai/code/session_01Rdc55TV8BuBqyKMSvWCEqP
</commit_message>
<xml_diff>
--- a/social/open-house-2026-10-16/open-house-oct16-v3-editable.pptx
+++ b/social/open-house-2026-10-16/open-house-oct16-v3-editable.pptx
@@ -973,7 +973,7 @@
       </p:pic>
       <p:pic>
         <p:nvPicPr>
-          <p:cNvPr id="6" name="micrograph-nematode" descr="micrograph nematode">    </p:cNvPr>
+          <p:cNvPr id="6" name="earthworm" descr="earthworm">    </p:cNvPr>
           <p:cNvPicPr>
             <a:picLocks noChangeAspect="1"/>
           </p:cNvPicPr>
@@ -981,78 +981,6 @@
         </p:nvPicPr>
         <p:blipFill>
           <a:blip r:embed="rId5"/>
-          <a:stretch>
-            <a:fillRect/>
-          </a:stretch>
-        </p:blipFill>
-        <p:spPr>
-          <a:xfrm>
-            <a:off x="2514600" y="8585200"/>
-            <a:ext cx="863600" cy="889000"/>
-          </a:xfrm>
-          <a:prstGeom prst="rect">
-            <a:avLst/>
-          </a:prstGeom>
-        </p:spPr>
-      </p:pic>
-      <p:pic>
-        <p:nvPicPr>
-          <p:cNvPr id="7" name="micrograph-fungal-hypha" descr="micrograph fungal hypha">    </p:cNvPr>
-          <p:cNvPicPr>
-            <a:picLocks noChangeAspect="1"/>
-          </p:cNvPicPr>
-          <p:nvPr/>
-        </p:nvPicPr>
-        <p:blipFill>
-          <a:blip r:embed="rId6"/>
-          <a:stretch>
-            <a:fillRect/>
-          </a:stretch>
-        </p:blipFill>
-        <p:spPr>
-          <a:xfrm>
-            <a:off x="4250267" y="8779933"/>
-            <a:ext cx="863600" cy="889000"/>
-          </a:xfrm>
-          <a:prstGeom prst="rect">
-            <a:avLst/>
-          </a:prstGeom>
-        </p:spPr>
-      </p:pic>
-      <p:pic>
-        <p:nvPicPr>
-          <p:cNvPr id="8" name="micrograph-amoeba" descr="micrograph amoeba">    </p:cNvPr>
-          <p:cNvPicPr>
-            <a:picLocks noChangeAspect="1"/>
-          </p:cNvPicPr>
-          <p:nvPr/>
-        </p:nvPicPr>
-        <p:blipFill>
-          <a:blip r:embed="rId7"/>
-          <a:stretch>
-            <a:fillRect/>
-          </a:stretch>
-        </p:blipFill>
-        <p:spPr>
-          <a:xfrm>
-            <a:off x="5985933" y="8585200"/>
-            <a:ext cx="863600" cy="889000"/>
-          </a:xfrm>
-          <a:prstGeom prst="rect">
-            <a:avLst/>
-          </a:prstGeom>
-        </p:spPr>
-      </p:pic>
-      <p:pic>
-        <p:nvPicPr>
-          <p:cNvPr id="9" name="earthworm" descr="earthworm">    </p:cNvPr>
-          <p:cNvPicPr>
-            <a:picLocks noChangeAspect="1"/>
-          </p:cNvPicPr>
-          <p:nvPr/>
-        </p:nvPicPr>
-        <p:blipFill>
-          <a:blip r:embed="rId8"/>
           <a:stretch>
             <a:fillRect/>
           </a:stretch>
@@ -1069,62 +997,14 @@
       </p:pic>
       <p:pic>
         <p:nvPicPr>
-          <p:cNvPr id="10" name="wall-frame-bacterial-feeding-nematode" descr="wall frame bacterial feeding nematode">    </p:cNvPr>
-          <p:cNvPicPr>
-            <a:picLocks noChangeAspect="1"/>
-          </p:cNvPicPr>
-          <p:nvPr/>
-        </p:nvPicPr>
-        <p:blipFill>
-          <a:blip r:embed="rId9"/>
-          <a:stretch>
-            <a:fillRect/>
-          </a:stretch>
-        </p:blipFill>
-        <p:spPr>
-          <a:xfrm>
-            <a:off x="2794000" y="2726267"/>
-            <a:ext cx="922867" cy="1286933"/>
-          </a:xfrm>
-          <a:prstGeom prst="rect">
-            <a:avLst/>
-          </a:prstGeom>
-        </p:spPr>
-      </p:pic>
-      <p:pic>
-        <p:nvPicPr>
-          <p:cNvPr id="11" name="wall-frame-testate-amoeba-arcella" descr="wall frame testate amoeba arcella">    </p:cNvPr>
-          <p:cNvPicPr>
-            <a:picLocks noChangeAspect="1"/>
-          </p:cNvPicPr>
-          <p:nvPr/>
-        </p:nvPicPr>
-        <p:blipFill>
-          <a:blip r:embed="rId10"/>
-          <a:stretch>
-            <a:fillRect/>
-          </a:stretch>
-        </p:blipFill>
-        <p:spPr>
-          <a:xfrm>
-            <a:off x="5926667" y="2726267"/>
-            <a:ext cx="922867" cy="1337733"/>
-          </a:xfrm>
-          <a:prstGeom prst="rect">
-            <a:avLst/>
-          </a:prstGeom>
-        </p:spPr>
-      </p:pic>
-      <p:pic>
-        <p:nvPicPr>
-          <p:cNvPr id="12" name="people-cheering-compost-cage" descr="people cheering compost cage">    </p:cNvPr>
-          <p:cNvPicPr>
-            <a:picLocks noChangeAspect="1"/>
-          </p:cNvPicPr>
-          <p:nvPr/>
-        </p:nvPicPr>
-        <p:blipFill>
-          <a:blip r:embed="rId11"/>
+          <p:cNvPr id="7" name="people-cheering-compost-cage" descr="people cheering compost cage">    </p:cNvPr>
+          <p:cNvPicPr>
+            <a:picLocks noChangeAspect="1"/>
+          </p:cNvPicPr>
+          <p:nvPr/>
+        </p:nvPicPr>
+        <p:blipFill>
+          <a:blip r:embed="rId6"/>
           <a:stretch>
             <a:fillRect/>
           </a:stretch>
@@ -1141,38 +1021,14 @@
       </p:pic>
       <p:pic>
         <p:nvPicPr>
-          <p:cNvPr id="13" name="person-misting-pile" descr="person misting pile">    </p:cNvPr>
-          <p:cNvPicPr>
-            <a:picLocks noChangeAspect="1"/>
-          </p:cNvPicPr>
-          <p:nvPr/>
-        </p:nvPicPr>
-        <p:blipFill>
-          <a:blip r:embed="rId12"/>
-          <a:stretch>
-            <a:fillRect/>
-          </a:stretch>
-        </p:blipFill>
-        <p:spPr>
-          <a:xfrm>
-            <a:off x="2269067" y="5232400"/>
-            <a:ext cx="1447800" cy="3124200"/>
-          </a:xfrm>
-          <a:prstGeom prst="rect">
-            <a:avLst/>
-          </a:prstGeom>
-        </p:spPr>
-      </p:pic>
-      <p:pic>
-        <p:nvPicPr>
-          <p:cNvPr id="14" name="person-kneeling-field" descr="person kneeling field">    </p:cNvPr>
-          <p:cNvPicPr>
-            <a:picLocks noChangeAspect="1"/>
-          </p:cNvPicPr>
-          <p:nvPr/>
-        </p:nvPicPr>
-        <p:blipFill>
-          <a:blip r:embed="rId13"/>
+          <p:cNvPr id="8" name="person-kneeling-field" descr="person kneeling field">    </p:cNvPr>
+          <p:cNvPicPr>
+            <a:picLocks noChangeAspect="1"/>
+          </p:cNvPicPr>
+          <p:nvPr/>
+        </p:nvPicPr>
+        <p:blipFill>
+          <a:blip r:embed="rId7"/>
           <a:stretch>
             <a:fillRect/>
           </a:stretch>
@@ -1189,14 +1045,14 @@
       </p:pic>
       <p:pic>
         <p:nvPicPr>
-          <p:cNvPr id="15" name="person-smelling-compost" descr="person smelling compost">    </p:cNvPr>
-          <p:cNvPicPr>
-            <a:picLocks noChangeAspect="1"/>
-          </p:cNvPicPr>
-          <p:nvPr/>
-        </p:nvPicPr>
-        <p:blipFill>
-          <a:blip r:embed="rId14"/>
+          <p:cNvPr id="9" name="person-smelling-compost" descr="person smelling compost">    </p:cNvPr>
+          <p:cNvPicPr>
+            <a:picLocks noChangeAspect="1"/>
+          </p:cNvPicPr>
+          <p:nvPr/>
+        </p:nvPicPr>
+        <p:blipFill>
+          <a:blip r:embed="rId8"/>
           <a:stretch>
             <a:fillRect/>
           </a:stretch>
@@ -1213,14 +1069,14 @@
       </p:pic>
       <p:pic>
         <p:nvPicPr>
-          <p:cNvPr id="16" name="poppies" descr="poppies">    </p:cNvPr>
-          <p:cNvPicPr>
-            <a:picLocks noChangeAspect="1"/>
-          </p:cNvPicPr>
-          <p:nvPr/>
-        </p:nvPicPr>
-        <p:blipFill>
-          <a:blip r:embed="rId15"/>
+          <p:cNvPr id="10" name="poppies" descr="poppies">    </p:cNvPr>
+          <p:cNvPicPr>
+            <a:picLocks noChangeAspect="1"/>
+          </p:cNvPicPr>
+          <p:nvPr/>
+        </p:nvPicPr>
+        <p:blipFill>
+          <a:blip r:embed="rId9"/>
           <a:stretch>
             <a:fillRect/>
           </a:stretch>
@@ -1237,14 +1093,14 @@
       </p:pic>
       <p:pic>
         <p:nvPicPr>
-          <p:cNvPr id="17" name="clover-room" descr="clover room">    </p:cNvPr>
-          <p:cNvPicPr>
-            <a:picLocks noChangeAspect="1"/>
-          </p:cNvPicPr>
-          <p:nvPr/>
-        </p:nvPicPr>
-        <p:blipFill>
-          <a:blip r:embed="rId16"/>
+          <p:cNvPr id="11" name="clover-room" descr="clover room">    </p:cNvPr>
+          <p:cNvPicPr>
+            <a:picLocks noChangeAspect="1"/>
+          </p:cNvPicPr>
+          <p:nvPr/>
+        </p:nvPicPr>
+        <p:blipFill>
+          <a:blip r:embed="rId10"/>
           <a:stretch>
             <a:fillRect/>
           </a:stretch>
@@ -1261,14 +1117,14 @@
       </p:pic>
       <p:pic>
         <p:nvPicPr>
-          <p:cNvPr id="18" name="sfw-caps" descr="sfw caps">    </p:cNvPr>
-          <p:cNvPicPr>
-            <a:picLocks noChangeAspect="1"/>
-          </p:cNvPicPr>
-          <p:nvPr/>
-        </p:nvPicPr>
-        <p:blipFill>
-          <a:blip r:embed="rId17"/>
+          <p:cNvPr id="12" name="sfw-caps" descr="sfw caps">    </p:cNvPr>
+          <p:cNvPicPr>
+            <a:picLocks noChangeAspect="1"/>
+          </p:cNvPicPr>
+          <p:nvPr/>
+        </p:nvPicPr>
+        <p:blipFill>
+          <a:blip r:embed="rId11"/>
           <a:stretch>
             <a:fillRect/>
           </a:stretch>
@@ -1285,14 +1141,14 @@
       </p:pic>
       <p:pic>
         <p:nvPicPr>
-          <p:cNvPr id="19" name="door-frame" descr="door frame">    </p:cNvPr>
-          <p:cNvPicPr>
-            <a:picLocks noChangeAspect="1"/>
-          </p:cNvPicPr>
-          <p:nvPr/>
-        </p:nvPicPr>
-        <p:blipFill>
-          <a:blip r:embed="rId18"/>
+          <p:cNvPr id="13" name="door-frame" descr="door frame">    </p:cNvPr>
+          <p:cNvPicPr>
+            <a:picLocks noChangeAspect="1"/>
+          </p:cNvPicPr>
+          <p:nvPr/>
+        </p:nvPicPr>
+        <p:blipFill>
+          <a:blip r:embed="rId12"/>
           <a:stretch>
             <a:fillRect/>
           </a:stretch>
@@ -1309,14 +1165,14 @@
       </p:pic>
       <p:pic>
         <p:nvPicPr>
-          <p:cNvPr id="20" name="front-door-open" descr="front door open">    </p:cNvPr>
-          <p:cNvPicPr>
-            <a:picLocks noChangeAspect="1"/>
-          </p:cNvPicPr>
-          <p:nvPr/>
-        </p:nvPicPr>
-        <p:blipFill>
-          <a:blip r:embed="rId19"/>
+          <p:cNvPr id="14" name="front-door-open" descr="front door open">    </p:cNvPr>
+          <p:cNvPicPr>
+            <a:picLocks noChangeAspect="1"/>
+          </p:cNvPicPr>
+          <p:nvPr/>
+        </p:nvPicPr>
+        <p:blipFill>
+          <a:blip r:embed="rId13"/>
           <a:stretch>
             <a:fillRect/>
           </a:stretch>
@@ -1333,14 +1189,14 @@
       </p:pic>
       <p:pic>
         <p:nvPicPr>
-          <p:cNvPr id="21" name="sfw-logo-door" descr="sfw logo door">    </p:cNvPr>
-          <p:cNvPicPr>
-            <a:picLocks noChangeAspect="1"/>
-          </p:cNvPicPr>
-          <p:nvPr/>
-        </p:nvPicPr>
-        <p:blipFill>
-          <a:blip r:embed="rId20"/>
+          <p:cNvPr id="15" name="sfw-logo-door" descr="sfw logo door">    </p:cNvPr>
+          <p:cNvPicPr>
+            <a:picLocks noChangeAspect="1"/>
+          </p:cNvPicPr>
+          <p:nvPr/>
+        </p:nvPicPr>
+        <p:blipFill>
+          <a:blip r:embed="rId14"/>
           <a:stretch>
             <a:fillRect/>
           </a:stretch>
@@ -1357,14 +1213,14 @@
       </p:pic>
       <p:pic>
         <p:nvPicPr>
-          <p:cNvPr id="22" name="vine" descr="vine">    </p:cNvPr>
-          <p:cNvPicPr>
-            <a:picLocks noChangeAspect="1"/>
-          </p:cNvPicPr>
-          <p:nvPr/>
-        </p:nvPicPr>
-        <p:blipFill>
-          <a:blip r:embed="rId21"/>
+          <p:cNvPr id="16" name="vine" descr="vine">    </p:cNvPr>
+          <p:cNvPicPr>
+            <a:picLocks noChangeAspect="1"/>
+          </p:cNvPicPr>
+          <p:nvPr/>
+        </p:nvPicPr>
+        <p:blipFill>
+          <a:blip r:embed="rId15"/>
           <a:stretch>
             <a:fillRect/>
           </a:stretch>
@@ -1381,14 +1237,14 @@
       </p:pic>
       <p:pic>
         <p:nvPicPr>
-          <p:cNvPr id="23" name="passion-flower" descr="passion flower">    </p:cNvPr>
-          <p:cNvPicPr>
-            <a:picLocks noChangeAspect="1"/>
-          </p:cNvPicPr>
-          <p:nvPr/>
-        </p:nvPicPr>
-        <p:blipFill>
-          <a:blip r:embed="rId22"/>
+          <p:cNvPr id="17" name="passion-flower" descr="passion flower">    </p:cNvPr>
+          <p:cNvPicPr>
+            <a:picLocks noChangeAspect="1"/>
+          </p:cNvPicPr>
+          <p:nvPr/>
+        </p:nvPicPr>
+        <p:blipFill>
+          <a:blip r:embed="rId16"/>
           <a:stretch>
             <a:fillRect/>
           </a:stretch>
@@ -1405,14 +1261,14 @@
       </p:pic>
       <p:pic>
         <p:nvPicPr>
-          <p:cNvPr id="24" name="orchid" descr="orchid">    </p:cNvPr>
-          <p:cNvPicPr>
-            <a:picLocks noChangeAspect="1"/>
-          </p:cNvPicPr>
-          <p:nvPr/>
-        </p:nvPicPr>
-        <p:blipFill>
-          <a:blip r:embed="rId23"/>
+          <p:cNvPr id="18" name="orchid" descr="orchid">    </p:cNvPr>
+          <p:cNvPicPr>
+            <a:picLocks noChangeAspect="1"/>
+          </p:cNvPicPr>
+          <p:nvPr/>
+        </p:nvPicPr>
+        <p:blipFill>
+          <a:blip r:embed="rId17"/>
           <a:stretch>
             <a:fillRect/>
           </a:stretch>
@@ -1429,14 +1285,14 @@
       </p:pic>
       <p:pic>
         <p:nvPicPr>
-          <p:cNvPr id="25" name="clover-in-pot" descr="clover in pot">    </p:cNvPr>
-          <p:cNvPicPr>
-            <a:picLocks noChangeAspect="1"/>
-          </p:cNvPicPr>
-          <p:nvPr/>
-        </p:nvPicPr>
-        <p:blipFill>
-          <a:blip r:embed="rId24"/>
+          <p:cNvPr id="19" name="clover-in-pot" descr="clover in pot">    </p:cNvPr>
+          <p:cNvPicPr>
+            <a:picLocks noChangeAspect="1"/>
+          </p:cNvPicPr>
+          <p:nvPr/>
+        </p:nvPicPr>
+        <p:blipFill>
+          <a:blip r:embed="rId18"/>
           <a:stretch>
             <a:fillRect/>
           </a:stretch>
@@ -1453,14 +1309,14 @@
       </p:pic>
       <p:pic>
         <p:nvPicPr>
-          <p:cNvPr id="26" name="pot" descr="pot">    </p:cNvPr>
-          <p:cNvPicPr>
-            <a:picLocks noChangeAspect="1"/>
-          </p:cNvPicPr>
-          <p:nvPr/>
-        </p:nvPicPr>
-        <p:blipFill>
-          <a:blip r:embed="rId25"/>
+          <p:cNvPr id="20" name="pot" descr="pot">    </p:cNvPr>
+          <p:cNvPicPr>
+            <a:picLocks noChangeAspect="1"/>
+          </p:cNvPicPr>
+          <p:nvPr/>
+        </p:nvPicPr>
+        <p:blipFill>
+          <a:blip r:embed="rId19"/>
           <a:stretch>
             <a:fillRect/>
           </a:stretch>
@@ -1477,14 +1333,14 @@
       </p:pic>
       <p:pic>
         <p:nvPicPr>
-          <p:cNvPr id="27" name="step" descr="step">    </p:cNvPr>
-          <p:cNvPicPr>
-            <a:picLocks noChangeAspect="1"/>
-          </p:cNvPicPr>
-          <p:nvPr/>
-        </p:nvPicPr>
-        <p:blipFill>
-          <a:blip r:embed="rId26"/>
+          <p:cNvPr id="21" name="step" descr="step">    </p:cNvPr>
+          <p:cNvPicPr>
+            <a:picLocks noChangeAspect="1"/>
+          </p:cNvPicPr>
+          <p:nvPr/>
+        </p:nvPicPr>
+        <p:blipFill>
+          <a:blip r:embed="rId20"/>
           <a:stretch>
             <a:fillRect/>
           </a:stretch>
@@ -1501,14 +1357,14 @@
       </p:pic>
       <p:pic>
         <p:nvPicPr>
-          <p:cNvPr id="28" name="doormat" descr="doormat">    </p:cNvPr>
-          <p:cNvPicPr>
-            <a:picLocks noChangeAspect="1"/>
-          </p:cNvPicPr>
-          <p:nvPr/>
-        </p:nvPicPr>
-        <p:blipFill>
-          <a:blip r:embed="rId27"/>
+          <p:cNvPr id="22" name="doormat" descr="doormat">    </p:cNvPr>
+          <p:cNvPicPr>
+            <a:picLocks noChangeAspect="1"/>
+          </p:cNvPicPr>
+          <p:nvPr/>
+        </p:nvPicPr>
+        <p:blipFill>
+          <a:blip r:embed="rId21"/>
           <a:stretch>
             <a:fillRect/>
           </a:stretch>
@@ -1525,124 +1381,7 @@
       </p:pic>
       <p:sp>
         <p:nvSpPr>
-          <p:cNvPr id="29" name="label-nematode"/>
-          <p:cNvSpPr txBox="1"/>
-          <p:nvPr/>
-        </p:nvSpPr>
-        <p:spPr>
-          <a:xfrm>
-            <a:off x="2243667" y="9440333"/>
-            <a:ext cx="1354667" cy="152400"/>
-          </a:xfrm>
-          <a:prstGeom prst="rect">
-            <a:avLst/>
-          </a:prstGeom>
-          <a:noFill/>
-          <a:ln/>
-        </p:spPr>
-        <p:txBody>
-          <a:bodyPr wrap="none" lIns="0" tIns="0" rIns="0" bIns="0" rtlCol="0" anchor="t"/>
-          <a:lstStyle/>
-          <a:p>
-            <a:pPr algn="ctr" indent="0" marL="0">
-              <a:buNone/>
-            </a:pPr>
-            <a:r>
-              <a:rPr lang="en-US" sz="870" b="1" dirty="0">
-                <a:solidFill>
-                  <a:srgbClr val="F4F1EA"/>
-                </a:solidFill>
-                <a:latin typeface="Montserrat" pitchFamily="34" charset="0"/>
-                <a:ea typeface="Montserrat" pitchFamily="34" charset="-122"/>
-                <a:cs typeface="Montserrat" pitchFamily="34" charset="-120"/>
-              </a:rPr>
-              <a:t>NEMATODE</a:t>
-            </a:r>
-            <a:endParaRPr lang="en-US" sz="870" dirty="0"/>
-          </a:p>
-        </p:txBody>
-      </p:sp>
-      <p:sp>
-        <p:nvSpPr>
-          <p:cNvPr id="30" name="label-fungal-hypha"/>
-          <p:cNvSpPr txBox="1"/>
-          <p:nvPr/>
-        </p:nvSpPr>
-        <p:spPr>
-          <a:xfrm>
-            <a:off x="3979333" y="9635067"/>
-            <a:ext cx="1354667" cy="152400"/>
-          </a:xfrm>
-          <a:prstGeom prst="rect">
-            <a:avLst/>
-          </a:prstGeom>
-          <a:noFill/>
-          <a:ln/>
-        </p:spPr>
-        <p:txBody>
-          <a:bodyPr wrap="none" lIns="0" tIns="0" rIns="0" bIns="0" rtlCol="0" anchor="t"/>
-          <a:lstStyle/>
-          <a:p>
-            <a:pPr algn="ctr" indent="0" marL="0">
-              <a:buNone/>
-            </a:pPr>
-            <a:r>
-              <a:rPr lang="en-US" sz="870" b="1" dirty="0">
-                <a:solidFill>
-                  <a:srgbClr val="F4F1EA"/>
-                </a:solidFill>
-                <a:latin typeface="Montserrat" pitchFamily="34" charset="0"/>
-                <a:ea typeface="Montserrat" pitchFamily="34" charset="-122"/>
-                <a:cs typeface="Montserrat" pitchFamily="34" charset="-120"/>
-              </a:rPr>
-              <a:t>FUNGAL HYPHA</a:t>
-            </a:r>
-            <a:endParaRPr lang="en-US" sz="870" dirty="0"/>
-          </a:p>
-        </p:txBody>
-      </p:sp>
-      <p:sp>
-        <p:nvSpPr>
-          <p:cNvPr id="31" name="label-amoeba"/>
-          <p:cNvSpPr txBox="1"/>
-          <p:nvPr/>
-        </p:nvSpPr>
-        <p:spPr>
-          <a:xfrm>
-            <a:off x="5715000" y="9440333"/>
-            <a:ext cx="1354667" cy="152400"/>
-          </a:xfrm>
-          <a:prstGeom prst="rect">
-            <a:avLst/>
-          </a:prstGeom>
-          <a:noFill/>
-          <a:ln/>
-        </p:spPr>
-        <p:txBody>
-          <a:bodyPr wrap="none" lIns="0" tIns="0" rIns="0" bIns="0" rtlCol="0" anchor="t"/>
-          <a:lstStyle/>
-          <a:p>
-            <a:pPr algn="ctr" indent="0" marL="0">
-              <a:buNone/>
-            </a:pPr>
-            <a:r>
-              <a:rPr lang="en-US" sz="870" b="1" dirty="0">
-                <a:solidFill>
-                  <a:srgbClr val="F4F1EA"/>
-                </a:solidFill>
-                <a:latin typeface="Montserrat" pitchFamily="34" charset="0"/>
-                <a:ea typeface="Montserrat" pitchFamily="34" charset="-122"/>
-                <a:cs typeface="Montserrat" pitchFamily="34" charset="-120"/>
-              </a:rPr>
-              <a:t>AMOEBA</a:t>
-            </a:r>
-            <a:endParaRPr lang="en-US" sz="870" dirty="0"/>
-          </a:p>
-        </p:txBody>
-      </p:sp>
-      <p:sp>
-        <p:nvSpPr>
-          <p:cNvPr id="32" name="date"/>
+          <p:cNvPr id="23" name="date"/>
           <p:cNvSpPr txBox="1"/>
           <p:nvPr/>
         </p:nvSpPr>
@@ -1681,7 +1420,7 @@
       </p:sp>
       <p:sp>
         <p:nvSpPr>
-          <p:cNvPr id="33" name="headline"/>
+          <p:cNvPr id="24" name="headline"/>
           <p:cNvSpPr txBox="1"/>
           <p:nvPr/>
         </p:nvSpPr>
@@ -1720,7 +1459,7 @@
       </p:sp>
       <p:sp>
         <p:nvSpPr>
-          <p:cNvPr id="34" name="subline"/>
+          <p:cNvPr id="25" name="subline"/>
           <p:cNvSpPr txBox="1"/>
           <p:nvPr/>
         </p:nvSpPr>

</xml_diff>

<commit_message>
Open House post v3: the cheering crew fills the doorway, as in Linnea's edit
Co-Authored-By: Claude Opus 5.5 <noreply@anthropic.com>
Claude-Session: https://claude.ai/code/session_01Rdc55TV8BuBqyKMSvWCEqP
</commit_message>
<xml_diff>
--- a/social/open-house-2026-10-16/open-house-oct16-v3-editable.pptx
+++ b/social/open-house-2026-10-16/open-house-oct16-v3-editable.pptx
@@ -949,7 +949,7 @@
       </p:pic>
       <p:pic>
         <p:nvPicPr>
-          <p:cNvPr id="5" name="mycelium-on-bark" descr="mycelium on bark">    </p:cNvPr>
+          <p:cNvPr id="5" name="earthworm" descr="earthworm">    </p:cNvPr>
           <p:cNvPicPr>
             <a:picLocks noChangeAspect="1"/>
           </p:cNvPicPr>
@@ -963,8 +963,8 @@
         </p:blipFill>
         <p:spPr>
           <a:xfrm>
-            <a:off x="6231467" y="9643533"/>
-            <a:ext cx="939800" cy="804333"/>
+            <a:off x="2446867" y="9711267"/>
+            <a:ext cx="1507067" cy="474133"/>
           </a:xfrm>
           <a:prstGeom prst="rect">
             <a:avLst/>
@@ -973,7 +973,7 @@
       </p:pic>
       <p:pic>
         <p:nvPicPr>
-          <p:cNvPr id="6" name="earthworm" descr="earthworm">    </p:cNvPr>
+          <p:cNvPr id="6" name="people-cheering-compost-cage" descr="people cheering compost cage">    </p:cNvPr>
           <p:cNvPicPr>
             <a:picLocks noChangeAspect="1"/>
           </p:cNvPicPr>
@@ -987,8 +987,8 @@
         </p:blipFill>
         <p:spPr>
           <a:xfrm>
-            <a:off x="2446867" y="9711267"/>
-            <a:ext cx="1507067" cy="474133"/>
+            <a:off x="2362200" y="3860800"/>
+            <a:ext cx="4436533" cy="4521200"/>
           </a:xfrm>
           <a:prstGeom prst="rect">
             <a:avLst/>
@@ -997,7 +997,7 @@
       </p:pic>
       <p:pic>
         <p:nvPicPr>
-          <p:cNvPr id="7" name="people-cheering-compost-cage" descr="people cheering compost cage">    </p:cNvPr>
+          <p:cNvPr id="7" name="door-frame" descr="door frame">    </p:cNvPr>
           <p:cNvPicPr>
             <a:picLocks noChangeAspect="1"/>
           </p:cNvPicPr>
@@ -1011,8 +1011,8 @@
         </p:blipFill>
         <p:spPr>
           <a:xfrm>
-            <a:off x="3403600" y="5723467"/>
-            <a:ext cx="2472267" cy="2531533"/>
+            <a:off x="1930400" y="2353733"/>
+            <a:ext cx="5461000" cy="7780867"/>
           </a:xfrm>
           <a:prstGeom prst="rect">
             <a:avLst/>
@@ -1021,7 +1021,7 @@
       </p:pic>
       <p:pic>
         <p:nvPicPr>
-          <p:cNvPr id="8" name="person-kneeling-field" descr="person kneeling field">    </p:cNvPr>
+          <p:cNvPr id="8" name="front-door-open" descr="front door open">    </p:cNvPr>
           <p:cNvPicPr>
             <a:picLocks noChangeAspect="1"/>
           </p:cNvPicPr>
@@ -1035,8 +1035,8 @@
         </p:blipFill>
         <p:spPr>
           <a:xfrm>
-            <a:off x="3826933" y="6705600"/>
-            <a:ext cx="1075267" cy="1684867"/>
+            <a:off x="423333" y="2142067"/>
+            <a:ext cx="1921933" cy="8890000"/>
           </a:xfrm>
           <a:prstGeom prst="rect">
             <a:avLst/>
@@ -1045,7 +1045,7 @@
       </p:pic>
       <p:pic>
         <p:nvPicPr>
-          <p:cNvPr id="9" name="person-smelling-compost" descr="person smelling compost">    </p:cNvPr>
+          <p:cNvPr id="9" name="sfw-logo-door" descr="sfw logo door">    </p:cNvPr>
           <p:cNvPicPr>
             <a:picLocks noChangeAspect="1"/>
           </p:cNvPicPr>
@@ -1059,8 +1059,8 @@
         </p:blipFill>
         <p:spPr>
           <a:xfrm>
-            <a:off x="4969933" y="5334000"/>
-            <a:ext cx="2243667" cy="3039533"/>
+            <a:off x="660400" y="3657600"/>
+            <a:ext cx="1253067" cy="1278467"/>
           </a:xfrm>
           <a:prstGeom prst="rect">
             <a:avLst/>
@@ -1069,7 +1069,7 @@
       </p:pic>
       <p:pic>
         <p:nvPicPr>
-          <p:cNvPr id="10" name="poppies" descr="poppies">    </p:cNvPr>
+          <p:cNvPr id="10" name="vine" descr="vine">    </p:cNvPr>
           <p:cNvPicPr>
             <a:picLocks noChangeAspect="1"/>
           </p:cNvPicPr>
@@ -1083,8 +1083,8 @@
         </p:blipFill>
         <p:spPr>
           <a:xfrm>
-            <a:off x="3344333" y="6536267"/>
-            <a:ext cx="1176867" cy="1769533"/>
+            <a:off x="7459133" y="3818467"/>
+            <a:ext cx="1490133" cy="6079067"/>
           </a:xfrm>
           <a:prstGeom prst="rect">
             <a:avLst/>
@@ -1093,7 +1093,7 @@
       </p:pic>
       <p:pic>
         <p:nvPicPr>
-          <p:cNvPr id="11" name="clover-room" descr="clover room">    </p:cNvPr>
+          <p:cNvPr id="11" name="passion-flower" descr="passion flower">    </p:cNvPr>
           <p:cNvPicPr>
             <a:picLocks noChangeAspect="1"/>
           </p:cNvPicPr>
@@ -1107,8 +1107,8 @@
         </p:blipFill>
         <p:spPr>
           <a:xfrm>
-            <a:off x="5232400" y="7035800"/>
-            <a:ext cx="668867" cy="1371600"/>
+            <a:off x="7399867" y="3200400"/>
+            <a:ext cx="1744133" cy="1803400"/>
           </a:xfrm>
           <a:prstGeom prst="rect">
             <a:avLst/>
@@ -1117,7 +1117,7 @@
       </p:pic>
       <p:pic>
         <p:nvPicPr>
-          <p:cNvPr id="12" name="sfw-caps" descr="sfw caps">    </p:cNvPr>
+          <p:cNvPr id="12" name="orchid" descr="orchid">    </p:cNvPr>
           <p:cNvPicPr>
             <a:picLocks noChangeAspect="1"/>
           </p:cNvPicPr>
@@ -1131,8 +1131,8 @@
         </p:blipFill>
         <p:spPr>
           <a:xfrm>
-            <a:off x="4402667" y="7755467"/>
-            <a:ext cx="1066800" cy="643467"/>
+            <a:off x="7662333" y="6011333"/>
+            <a:ext cx="1413933" cy="1075267"/>
           </a:xfrm>
           <a:prstGeom prst="rect">
             <a:avLst/>
@@ -1141,7 +1141,7 @@
       </p:pic>
       <p:pic>
         <p:nvPicPr>
-          <p:cNvPr id="13" name="door-frame" descr="door frame">    </p:cNvPr>
+          <p:cNvPr id="13" name="pot" descr="pot">    </p:cNvPr>
           <p:cNvPicPr>
             <a:picLocks noChangeAspect="1"/>
           </p:cNvPicPr>
@@ -1155,8 +1155,8 @@
         </p:blipFill>
         <p:spPr>
           <a:xfrm>
-            <a:off x="1930400" y="2353733"/>
-            <a:ext cx="5461000" cy="7780867"/>
+            <a:off x="7620000" y="9702800"/>
+            <a:ext cx="1236133" cy="956733"/>
           </a:xfrm>
           <a:prstGeom prst="rect">
             <a:avLst/>
@@ -1165,7 +1165,7 @@
       </p:pic>
       <p:pic>
         <p:nvPicPr>
-          <p:cNvPr id="14" name="front-door-open" descr="front door open">    </p:cNvPr>
+          <p:cNvPr id="14" name="step" descr="step">    </p:cNvPr>
           <p:cNvPicPr>
             <a:picLocks noChangeAspect="1"/>
           </p:cNvPicPr>
@@ -1179,8 +1179,8 @@
         </p:blipFill>
         <p:spPr>
           <a:xfrm>
-            <a:off x="423333" y="2142067"/>
-            <a:ext cx="1921933" cy="8890000"/>
+            <a:off x="1710267" y="10126133"/>
+            <a:ext cx="5901267" cy="296333"/>
           </a:xfrm>
           <a:prstGeom prst="rect">
             <a:avLst/>
@@ -1189,7 +1189,7 @@
       </p:pic>
       <p:pic>
         <p:nvPicPr>
-          <p:cNvPr id="15" name="sfw-logo-door" descr="sfw logo door">    </p:cNvPr>
+          <p:cNvPr id="15" name="doormat" descr="doormat">    </p:cNvPr>
           <p:cNvPicPr>
             <a:picLocks noChangeAspect="1"/>
           </p:cNvPicPr>
@@ -1203,174 +1203,6 @@
         </p:blipFill>
         <p:spPr>
           <a:xfrm>
-            <a:off x="660400" y="3657600"/>
-            <a:ext cx="1253067" cy="1278467"/>
-          </a:xfrm>
-          <a:prstGeom prst="rect">
-            <a:avLst/>
-          </a:prstGeom>
-        </p:spPr>
-      </p:pic>
-      <p:pic>
-        <p:nvPicPr>
-          <p:cNvPr id="16" name="vine" descr="vine">    </p:cNvPr>
-          <p:cNvPicPr>
-            <a:picLocks noChangeAspect="1"/>
-          </p:cNvPicPr>
-          <p:nvPr/>
-        </p:nvPicPr>
-        <p:blipFill>
-          <a:blip r:embed="rId15"/>
-          <a:stretch>
-            <a:fillRect/>
-          </a:stretch>
-        </p:blipFill>
-        <p:spPr>
-          <a:xfrm>
-            <a:off x="7459133" y="3818467"/>
-            <a:ext cx="1490133" cy="6079067"/>
-          </a:xfrm>
-          <a:prstGeom prst="rect">
-            <a:avLst/>
-          </a:prstGeom>
-        </p:spPr>
-      </p:pic>
-      <p:pic>
-        <p:nvPicPr>
-          <p:cNvPr id="17" name="passion-flower" descr="passion flower">    </p:cNvPr>
-          <p:cNvPicPr>
-            <a:picLocks noChangeAspect="1"/>
-          </p:cNvPicPr>
-          <p:nvPr/>
-        </p:nvPicPr>
-        <p:blipFill>
-          <a:blip r:embed="rId16"/>
-          <a:stretch>
-            <a:fillRect/>
-          </a:stretch>
-        </p:blipFill>
-        <p:spPr>
-          <a:xfrm>
-            <a:off x="7399867" y="3200400"/>
-            <a:ext cx="1744133" cy="1803400"/>
-          </a:xfrm>
-          <a:prstGeom prst="rect">
-            <a:avLst/>
-          </a:prstGeom>
-        </p:spPr>
-      </p:pic>
-      <p:pic>
-        <p:nvPicPr>
-          <p:cNvPr id="18" name="orchid" descr="orchid">    </p:cNvPr>
-          <p:cNvPicPr>
-            <a:picLocks noChangeAspect="1"/>
-          </p:cNvPicPr>
-          <p:nvPr/>
-        </p:nvPicPr>
-        <p:blipFill>
-          <a:blip r:embed="rId17"/>
-          <a:stretch>
-            <a:fillRect/>
-          </a:stretch>
-        </p:blipFill>
-        <p:spPr>
-          <a:xfrm>
-            <a:off x="7662333" y="6011333"/>
-            <a:ext cx="1413933" cy="1075267"/>
-          </a:xfrm>
-          <a:prstGeom prst="rect">
-            <a:avLst/>
-          </a:prstGeom>
-        </p:spPr>
-      </p:pic>
-      <p:pic>
-        <p:nvPicPr>
-          <p:cNvPr id="19" name="clover-in-pot" descr="clover in pot">    </p:cNvPr>
-          <p:cNvPicPr>
-            <a:picLocks noChangeAspect="1"/>
-          </p:cNvPicPr>
-          <p:nvPr/>
-        </p:nvPicPr>
-        <p:blipFill>
-          <a:blip r:embed="rId18"/>
-          <a:stretch>
-            <a:fillRect/>
-          </a:stretch>
-        </p:blipFill>
-        <p:spPr>
-          <a:xfrm>
-            <a:off x="7857067" y="8390467"/>
-            <a:ext cx="838200" cy="1811867"/>
-          </a:xfrm>
-          <a:prstGeom prst="rect">
-            <a:avLst/>
-          </a:prstGeom>
-        </p:spPr>
-      </p:pic>
-      <p:pic>
-        <p:nvPicPr>
-          <p:cNvPr id="20" name="pot" descr="pot">    </p:cNvPr>
-          <p:cNvPicPr>
-            <a:picLocks noChangeAspect="1"/>
-          </p:cNvPicPr>
-          <p:nvPr/>
-        </p:nvPicPr>
-        <p:blipFill>
-          <a:blip r:embed="rId19"/>
-          <a:stretch>
-            <a:fillRect/>
-          </a:stretch>
-        </p:blipFill>
-        <p:spPr>
-          <a:xfrm>
-            <a:off x="7620000" y="9702800"/>
-            <a:ext cx="1236133" cy="956733"/>
-          </a:xfrm>
-          <a:prstGeom prst="rect">
-            <a:avLst/>
-          </a:prstGeom>
-        </p:spPr>
-      </p:pic>
-      <p:pic>
-        <p:nvPicPr>
-          <p:cNvPr id="21" name="step" descr="step">    </p:cNvPr>
-          <p:cNvPicPr>
-            <a:picLocks noChangeAspect="1"/>
-          </p:cNvPicPr>
-          <p:nvPr/>
-        </p:nvPicPr>
-        <p:blipFill>
-          <a:blip r:embed="rId20"/>
-          <a:stretch>
-            <a:fillRect/>
-          </a:stretch>
-        </p:blipFill>
-        <p:spPr>
-          <a:xfrm>
-            <a:off x="1710267" y="10126133"/>
-            <a:ext cx="5901267" cy="296333"/>
-          </a:xfrm>
-          <a:prstGeom prst="rect">
-            <a:avLst/>
-          </a:prstGeom>
-        </p:spPr>
-      </p:pic>
-      <p:pic>
-        <p:nvPicPr>
-          <p:cNvPr id="22" name="doormat" descr="doormat">    </p:cNvPr>
-          <p:cNvPicPr>
-            <a:picLocks noChangeAspect="1"/>
-          </p:cNvPicPr>
-          <p:nvPr/>
-        </p:nvPicPr>
-        <p:blipFill>
-          <a:blip r:embed="rId21"/>
-          <a:stretch>
-            <a:fillRect/>
-          </a:stretch>
-        </p:blipFill>
-        <p:spPr>
-          <a:xfrm>
             <a:off x="2582333" y="10464800"/>
             <a:ext cx="4030133" cy="855133"/>
           </a:xfrm>
@@ -1381,7 +1213,7 @@
       </p:pic>
       <p:sp>
         <p:nvSpPr>
-          <p:cNvPr id="23" name="date"/>
+          <p:cNvPr id="16" name="date"/>
           <p:cNvSpPr txBox="1"/>
           <p:nvPr/>
         </p:nvSpPr>
@@ -1420,7 +1252,7 @@
       </p:sp>
       <p:sp>
         <p:nvSpPr>
-          <p:cNvPr id="24" name="headline"/>
+          <p:cNvPr id="17" name="headline"/>
           <p:cNvSpPr txBox="1"/>
           <p:nvPr/>
         </p:nvSpPr>
@@ -1459,7 +1291,7 @@
       </p:sp>
       <p:sp>
         <p:nvSpPr>
-          <p:cNvPr id="25" name="subline"/>
+          <p:cNvPr id="18" name="subline"/>
           <p:cNvSpPr txBox="1"/>
           <p:nvPr/>
         </p:nvSpPr>

</xml_diff>